<commit_message>
Deck edits: Discussion Notes boxes, drop immediate actions, organ-direct on strategy
- Slide 5 (operating model): two-lane callout replaced with a Discussion Notes box for
  live capture during the meeting, matching the pattern the user set. The domestic vs
  EU-bound rule still appears on slide 3, so nothing is lost.
- Slide 7 (next steps): removed the gate line and the Immediate Actions block per
  request; a Discussion Notes box takes that space.
- Slide 2 (introduction): the strategy card now names organ-direct suppliers
  (Smithfield BioScience, Midwest Research Swine, Tissue Source) as one of the supplier
  types being decided, alongside size tier, certifications, welfare culture, Model A/B
  and regions.
- Slide 3 left untouched as requested.

QA: validate passes, bounds and text-fit clean across all 7 slides.

Co-Authored-By: Claude Opus 5 <noreply@anthropic.com>
Claude-Session: https://claude.ai/code/session_01JvB48tbAk8juvoi9bxkFTf
</commit_message>
<xml_diff>
--- a/Tissue Supplier Research/Supplier_Strategy_Meeting.pptx
+++ b/Tissue Supplier Research/Supplier_Strategy_Meeting.pptx
@@ -3292,11 +3292,11 @@
         <p:spPr>
           <a:xfrm>
             <a:off x="548640" y="2761488"/>
-            <a:ext cx="5349240" cy="2286000"/>
+            <a:ext cx="5349240" cy="2395728"/>
           </a:xfrm>
           <a:prstGeom prst="roundRect">
             <a:avLst>
-              <a:gd name="adj" fmla="val 3200"/>
+              <a:gd name="adj" fmla="val 3053"/>
             </a:avLst>
           </a:prstGeom>
           <a:solidFill>
@@ -3421,8 +3421,8 @@
         </p:nvSpPr>
         <p:spPr>
           <a:xfrm>
-            <a:off x="932688" y="3675888"/>
-            <a:ext cx="4617720" cy="1188720"/>
+            <a:off x="932688" y="3621024"/>
+            <a:ext cx="4617720" cy="1426464"/>
           </a:xfrm>
           <a:prstGeom prst="rect">
             <a:avLst/>
@@ -3436,12 +3436,12 @@
           <a:p>
             <a:pPr indent="0" marL="0">
               <a:lnSpc>
-                <a:spcPts val="2000"/>
+                <a:spcPts val="1800"/>
               </a:lnSpc>
               <a:buNone/>
             </a:pPr>
             <a:r>
-              <a:rPr lang="en-US" sz="1400" dirty="0">
+              <a:rPr lang="en-US" sz="1300" dirty="0">
                 <a:solidFill>
                   <a:srgbClr val="2B2B2B"/>
                 </a:solidFill>
@@ -3451,17 +3451,17 @@
               </a:rPr>
               <a:t>What kind of supplier are we actually buying?</a:t>
             </a:r>
-            <a:endParaRPr lang="en-US" sz="1400" dirty="0"/>
+            <a:endParaRPr lang="en-US" sz="1300" dirty="0"/>
           </a:p>
           <a:p>
             <a:pPr indent="0" marL="0">
               <a:lnSpc>
-                <a:spcPts val="2000"/>
+                <a:spcPts val="1800"/>
               </a:lnSpc>
               <a:buNone/>
             </a:pPr>
             <a:r>
-              <a:rPr lang="en-US" sz="1400" dirty="0">
+              <a:rPr lang="en-US" sz="1300" dirty="0">
                 <a:solidFill>
                   <a:srgbClr val="2B2B2B"/>
                 </a:solidFill>
@@ -3471,17 +3471,17 @@
               </a:rPr>
               <a:t>Size tier · certifications · welfare culture ·</a:t>
             </a:r>
-            <a:endParaRPr lang="en-US" sz="1400" dirty="0"/>
+            <a:endParaRPr lang="en-US" sz="1300" dirty="0"/>
           </a:p>
           <a:p>
             <a:pPr indent="0" marL="0">
               <a:lnSpc>
-                <a:spcPts val="2000"/>
+                <a:spcPts val="1800"/>
               </a:lnSpc>
               <a:buNone/>
             </a:pPr>
             <a:r>
-              <a:rPr lang="en-US" sz="1400" dirty="0">
+              <a:rPr lang="en-US" sz="1300" dirty="0">
                 <a:solidFill>
                   <a:srgbClr val="2B2B2B"/>
                 </a:solidFill>
@@ -3489,9 +3489,49 @@
                 <a:ea typeface="Calibri" pitchFamily="34" charset="-122"/>
                 <a:cs typeface="Calibri" pitchFamily="34" charset="-120"/>
               </a:rPr>
-              <a:t>Model A or Model B · which regions.</a:t>
-            </a:r>
-            <a:endParaRPr lang="en-US" sz="1400" dirty="0"/>
+              <a:t>Model A or Model B · which regions ·</a:t>
+            </a:r>
+            <a:endParaRPr lang="en-US" sz="1300" dirty="0"/>
+          </a:p>
+          <a:p>
+            <a:pPr indent="0" marL="0">
+              <a:lnSpc>
+                <a:spcPts val="1800"/>
+              </a:lnSpc>
+              <a:buNone/>
+            </a:pPr>
+            <a:r>
+              <a:rPr lang="en-US" sz="1300" dirty="0">
+                <a:solidFill>
+                  <a:srgbClr val="2B2B2B"/>
+                </a:solidFill>
+                <a:latin typeface="Calibri" pitchFamily="34" charset="0"/>
+                <a:ea typeface="Calibri" pitchFamily="34" charset="-122"/>
+                <a:cs typeface="Calibri" pitchFamily="34" charset="-120"/>
+              </a:rPr>
+              <a:t>and organ-direct suppliers (Smithfield BioScience,</a:t>
+            </a:r>
+            <a:endParaRPr lang="en-US" sz="1300" dirty="0"/>
+          </a:p>
+          <a:p>
+            <a:pPr indent="0" marL="0">
+              <a:lnSpc>
+                <a:spcPts val="1800"/>
+              </a:lnSpc>
+              <a:buNone/>
+            </a:pPr>
+            <a:r>
+              <a:rPr lang="en-US" sz="1300" dirty="0">
+                <a:solidFill>
+                  <a:srgbClr val="2B2B2B"/>
+                </a:solidFill>
+                <a:latin typeface="Calibri" pitchFamily="34" charset="0"/>
+                <a:ea typeface="Calibri" pitchFamily="34" charset="-122"/>
+                <a:cs typeface="Calibri" pitchFamily="34" charset="-120"/>
+              </a:rPr>
+              <a:t>Midwest Research Swine, Tissue Source).</a:t>
+            </a:r>
+            <a:endParaRPr lang="en-US" sz="1300" dirty="0"/>
           </a:p>
         </p:txBody>
       </p:sp>
@@ -3504,11 +3544,11 @@
         <p:spPr>
           <a:xfrm>
             <a:off x="6263640" y="2761488"/>
-            <a:ext cx="5349240" cy="2286000"/>
+            <a:ext cx="5349240" cy="2395728"/>
           </a:xfrm>
           <a:prstGeom prst="roundRect">
             <a:avLst>
-              <a:gd name="adj" fmla="val 3200"/>
+              <a:gd name="adj" fmla="val 3053"/>
             </a:avLst>
           </a:prstGeom>
           <a:solidFill>
@@ -3633,8 +3673,8 @@
         </p:nvSpPr>
         <p:spPr>
           <a:xfrm>
-            <a:off x="6647688" y="3675888"/>
-            <a:ext cx="4617720" cy="1188720"/>
+            <a:off x="6647688" y="3621024"/>
+            <a:ext cx="4617720" cy="1426464"/>
           </a:xfrm>
           <a:prstGeom prst="rect">
             <a:avLst/>
@@ -3648,12 +3688,12 @@
           <a:p>
             <a:pPr indent="0" marL="0">
               <a:lnSpc>
-                <a:spcPts val="2000"/>
+                <a:spcPts val="1800"/>
               </a:lnSpc>
               <a:buNone/>
             </a:pPr>
             <a:r>
-              <a:rPr lang="en-US" sz="1400" dirty="0">
+              <a:rPr lang="en-US" sz="1300" dirty="0">
                 <a:solidFill>
                   <a:srgbClr val="2B2B2B"/>
                 </a:solidFill>
@@ -3663,17 +3703,17 @@
               </a:rPr>
               <a:t>How we go from Tissue Supplier LEAD to</a:t>
             </a:r>
-            <a:endParaRPr lang="en-US" sz="1400" dirty="0"/>
+            <a:endParaRPr lang="en-US" sz="1300" dirty="0"/>
           </a:p>
           <a:p>
             <a:pPr indent="0" marL="0">
               <a:lnSpc>
-                <a:spcPts val="2000"/>
+                <a:spcPts val="1800"/>
               </a:lnSpc>
               <a:buNone/>
             </a:pPr>
             <a:r>
-              <a:rPr lang="en-US" sz="1400" dirty="0">
+              <a:rPr lang="en-US" sz="1300" dirty="0">
                 <a:solidFill>
                   <a:srgbClr val="2B2B2B"/>
                 </a:solidFill>
@@ -3683,17 +3723,17 @@
               </a:rPr>
               <a:t>Tissue Supplier ONBOARDED — the steps, the</a:t>
             </a:r>
-            <a:endParaRPr lang="en-US" sz="1400" dirty="0"/>
+            <a:endParaRPr lang="en-US" sz="1300" dirty="0"/>
           </a:p>
           <a:p>
             <a:pPr indent="0" marL="0">
               <a:lnSpc>
-                <a:spcPts val="2000"/>
+                <a:spcPts val="1800"/>
               </a:lnSpc>
               <a:buNone/>
             </a:pPr>
             <a:r>
-              <a:rPr lang="en-US" sz="1400" dirty="0">
+              <a:rPr lang="en-US" sz="1300" dirty="0">
                 <a:solidFill>
                   <a:srgbClr val="2B2B2B"/>
                 </a:solidFill>
@@ -3703,7 +3743,7 @@
               </a:rPr>
               <a:t>gates, and who owns each one.</a:t>
             </a:r>
-            <a:endParaRPr lang="en-US" sz="1400" dirty="0"/>
+            <a:endParaRPr lang="en-US" sz="1300" dirty="0"/>
           </a:p>
         </p:txBody>
       </p:sp>
@@ -3715,7 +3755,7 @@
         </p:nvSpPr>
         <p:spPr>
           <a:xfrm>
-            <a:off x="548640" y="5349240"/>
+            <a:off x="548640" y="5468112"/>
             <a:ext cx="11064240" cy="320040"/>
           </a:xfrm>
           <a:prstGeom prst="rect">
@@ -6283,11 +6323,11 @@
         <p:spPr>
           <a:xfrm>
             <a:off x="548640" y="4956048"/>
-            <a:ext cx="11064240" cy="786384"/>
+            <a:ext cx="11064240" cy="932688"/>
           </a:xfrm>
           <a:prstGeom prst="roundRect">
             <a:avLst>
-              <a:gd name="adj" fmla="val 9302"/>
+              <a:gd name="adj" fmla="val 7843"/>
             </a:avLst>
           </a:prstGeom>
           <a:solidFill>
@@ -6309,24 +6349,24 @@
         </p:nvSpPr>
         <p:spPr>
           <a:xfrm>
-            <a:off x="822960" y="4956048"/>
-            <a:ext cx="10515600" cy="786384"/>
-          </a:xfrm>
-          <a:prstGeom prst="rect">
-            <a:avLst/>
-          </a:prstGeom>
-          <a:noFill/>
-          <a:ln/>
-        </p:spPr>
-        <p:txBody>
-          <a:bodyPr wrap="square" lIns="0" tIns="0" rIns="0" bIns="0" rtlCol="0" anchor="ctr"/>
-          <a:lstStyle/>
-          <a:p>
-            <a:pPr indent="0" marL="0">
-              <a:buNone/>
-            </a:pPr>
-            <a:r>
-              <a:rPr lang="en-US" sz="1350" b="1" dirty="0">
+            <a:off x="822960" y="5084064"/>
+            <a:ext cx="4572000" cy="274320"/>
+          </a:xfrm>
+          <a:prstGeom prst="rect">
+            <a:avLst/>
+          </a:prstGeom>
+          <a:noFill/>
+          <a:ln/>
+        </p:spPr>
+        <p:txBody>
+          <a:bodyPr wrap="square" lIns="0" tIns="0" rIns="0" bIns="0" rtlCol="0" anchor="ctr"/>
+          <a:lstStyle/>
+          <a:p>
+            <a:pPr indent="0" marL="0">
+              <a:buNone/>
+            </a:pPr>
+            <a:r>
+              <a:rPr lang="en-US" sz="1200" b="1" dirty="0">
                 <a:solidFill>
                   <a:srgbClr val="8C2F39"/>
                 </a:solidFill>
@@ -6334,9 +6374,9 @@
                 <a:ea typeface="Calibri" pitchFamily="34" charset="-122"/>
                 <a:cs typeface="Calibri" pitchFamily="34" charset="-120"/>
               </a:rPr>
-              <a:t>Two lanes, not one:   DOMESTIC — Nahunta anchors it, state-inspected is fine.    EU-BOUND — federally-inspected plant, APHIS-listed, no exceptions.</a:t>
-            </a:r>
-            <a:endParaRPr lang="en-US" sz="1350" dirty="0"/>
+              <a:t>Discussion Notes:</a:t>
+            </a:r>
+            <a:endParaRPr lang="en-US" sz="1200" dirty="0"/>
           </a:p>
         </p:txBody>
       </p:sp>
@@ -6348,7 +6388,7 @@
         </p:nvSpPr>
         <p:spPr>
           <a:xfrm>
-            <a:off x="548640" y="5907024"/>
+            <a:off x="548640" y="6035040"/>
             <a:ext cx="11064240" cy="320040"/>
           </a:xfrm>
           <a:prstGeom prst="rect">
@@ -9328,104 +9368,26 @@
       </p:sp>
       <p:sp>
         <p:nvSpPr>
-          <p:cNvPr id="41" name="Text 39"/>
-          <p:cNvSpPr/>
-          <p:nvPr/>
-        </p:nvSpPr>
-        <p:spPr>
-          <a:xfrm>
-            <a:off x="548640" y="4315968"/>
-            <a:ext cx="11064240" cy="292608"/>
-          </a:xfrm>
-          <a:prstGeom prst="rect">
-            <a:avLst/>
-          </a:prstGeom>
-          <a:noFill/>
-          <a:ln/>
-        </p:spPr>
-        <p:txBody>
-          <a:bodyPr wrap="square" lIns="0" tIns="0" rIns="0" bIns="0" rtlCol="0" anchor="ctr"/>
-          <a:lstStyle/>
-          <a:p>
-            <a:pPr indent="0" marL="0">
-              <a:buNone/>
-            </a:pPr>
-            <a:r>
-              <a:rPr lang="en-US" sz="1250" i="1" dirty="0">
-                <a:solidFill>
-                  <a:srgbClr val="6E6E6E"/>
-                </a:solidFill>
-                <a:latin typeface="Calibri" pitchFamily="34" charset="0"/>
-                <a:ea typeface="Calibri" pitchFamily="34" charset="-122"/>
-                <a:cs typeface="Calibri" pitchFamily="34" charset="-120"/>
-              </a:rPr>
-              <a:t>Each arrow is a GATE — we only spend the next step's effort if the previous one passed.</a:t>
-            </a:r>
-            <a:endParaRPr lang="en-US" sz="1250" dirty="0"/>
-          </a:p>
-        </p:txBody>
-      </p:sp>
-      <p:sp>
-        <p:nvSpPr>
-          <p:cNvPr id="42" name="Text 40"/>
-          <p:cNvSpPr/>
-          <p:nvPr/>
-        </p:nvSpPr>
-        <p:spPr>
-          <a:xfrm>
-            <a:off x="548640" y="4809744"/>
-            <a:ext cx="7315200" cy="274320"/>
-          </a:xfrm>
-          <a:prstGeom prst="rect">
-            <a:avLst/>
-          </a:prstGeom>
-          <a:noFill/>
-          <a:ln/>
-        </p:spPr>
-        <p:txBody>
-          <a:bodyPr wrap="square" lIns="0" tIns="0" rIns="0" bIns="0" rtlCol="0" anchor="ctr"/>
-          <a:lstStyle/>
-          <a:p>
-            <a:pPr indent="0" marL="0">
-              <a:buNone/>
-            </a:pPr>
-            <a:r>
-              <a:rPr lang="en-US" sz="1200" b="1" spc="150" kern="0" dirty="0">
-                <a:solidFill>
-                  <a:srgbClr val="A26769"/>
-                </a:solidFill>
-                <a:latin typeface="Calibri" pitchFamily="34" charset="0"/>
-                <a:ea typeface="Calibri" pitchFamily="34" charset="-122"/>
-                <a:cs typeface="Calibri" pitchFamily="34" charset="-120"/>
-              </a:rPr>
-              <a:t>IMMEDIATE ACTIONS</a:t>
-            </a:r>
-            <a:endParaRPr lang="en-US" sz="1200" dirty="0"/>
-          </a:p>
-        </p:txBody>
-      </p:sp>
-      <p:sp>
-        <p:nvSpPr>
-          <p:cNvPr id="43" name="Shape 41"/>
-          <p:cNvSpPr/>
-          <p:nvPr/>
-        </p:nvSpPr>
-        <p:spPr>
-          <a:xfrm>
-            <a:off x="548640" y="5138928"/>
-            <a:ext cx="3566160" cy="822960"/>
+          <p:cNvPr id="41" name="Shape 39"/>
+          <p:cNvSpPr/>
+          <p:nvPr/>
+        </p:nvSpPr>
+        <p:spPr>
+          <a:xfrm>
+            <a:off x="548640" y="4443984"/>
+            <a:ext cx="11064240" cy="1170432"/>
           </a:xfrm>
           <a:prstGeom prst="roundRect">
             <a:avLst>
-              <a:gd name="adj" fmla="val 8889"/>
+              <a:gd name="adj" fmla="val 6250"/>
             </a:avLst>
           </a:prstGeom>
           <a:solidFill>
-            <a:srgbClr val="F7F0F1"/>
+            <a:srgbClr val="F6E4E4"/>
           </a:solidFill>
           <a:ln w="12700">
             <a:solidFill>
-              <a:srgbClr val="F7F0F1"/>
+              <a:srgbClr val="F6E4E4"/>
             </a:solidFill>
             <a:prstDash val="solid"/>
           </a:ln>
@@ -9433,328 +9395,79 @@
       </p:sp>
       <p:sp>
         <p:nvSpPr>
-          <p:cNvPr id="44" name="Text 42"/>
-          <p:cNvSpPr/>
-          <p:nvPr/>
-        </p:nvSpPr>
-        <p:spPr>
-          <a:xfrm>
-            <a:off x="749808" y="5230368"/>
-            <a:ext cx="3200400" cy="274320"/>
-          </a:xfrm>
-          <a:prstGeom prst="rect">
-            <a:avLst/>
-          </a:prstGeom>
-          <a:noFill/>
-          <a:ln/>
-        </p:spPr>
-        <p:txBody>
-          <a:bodyPr wrap="square" lIns="0" tIns="0" rIns="0" bIns="0" rtlCol="0" anchor="ctr"/>
-          <a:lstStyle/>
-          <a:p>
-            <a:pPr indent="0" marL="0">
-              <a:buNone/>
-            </a:pPr>
-            <a:r>
-              <a:rPr lang="en-US" sz="1350" b="1" dirty="0">
+          <p:cNvPr id="42" name="Text 40"/>
+          <p:cNvSpPr/>
+          <p:nvPr/>
+        </p:nvSpPr>
+        <p:spPr>
+          <a:xfrm>
+            <a:off x="822960" y="4572000"/>
+            <a:ext cx="4572000" cy="274320"/>
+          </a:xfrm>
+          <a:prstGeom prst="rect">
+            <a:avLst/>
+          </a:prstGeom>
+          <a:noFill/>
+          <a:ln/>
+        </p:spPr>
+        <p:txBody>
+          <a:bodyPr wrap="square" lIns="0" tIns="0" rIns="0" bIns="0" rtlCol="0" anchor="ctr"/>
+          <a:lstStyle/>
+          <a:p>
+            <a:pPr indent="0" marL="0">
+              <a:buNone/>
+            </a:pPr>
+            <a:r>
+              <a:rPr lang="en-US" sz="1200" b="1" dirty="0">
+                <a:solidFill>
+                  <a:srgbClr val="8C2F39"/>
+                </a:solidFill>
+                <a:latin typeface="Calibri" pitchFamily="34" charset="0"/>
+                <a:ea typeface="Calibri" pitchFamily="34" charset="-122"/>
+                <a:cs typeface="Calibri" pitchFamily="34" charset="-120"/>
+              </a:rPr>
+              <a:t>Discussion Notes:</a:t>
+            </a:r>
+            <a:endParaRPr lang="en-US" sz="1200" dirty="0"/>
+          </a:p>
+        </p:txBody>
+      </p:sp>
+      <p:sp>
+        <p:nvSpPr>
+          <p:cNvPr id="43" name="Text 41"/>
+          <p:cNvSpPr/>
+          <p:nvPr/>
+        </p:nvSpPr>
+        <p:spPr>
+          <a:xfrm>
+            <a:off x="548640" y="5760720"/>
+            <a:ext cx="11064240" cy="310896"/>
+          </a:xfrm>
+          <a:prstGeom prst="rect">
+            <a:avLst/>
+          </a:prstGeom>
+          <a:noFill/>
+          <a:ln/>
+        </p:spPr>
+        <p:txBody>
+          <a:bodyPr wrap="square" lIns="0" tIns="0" rIns="0" bIns="0" rtlCol="0" anchor="ctr"/>
+          <a:lstStyle/>
+          <a:p>
+            <a:pPr indent="0" marL="0">
+              <a:buNone/>
+            </a:pPr>
+            <a:r>
+              <a:rPr lang="en-US" sz="1350" i="1" dirty="0">
                 <a:solidFill>
                   <a:srgbClr val="6D2E46"/>
                 </a:solidFill>
-                <a:latin typeface="Cambria" pitchFamily="34" charset="0"/>
-                <a:ea typeface="Cambria" pitchFamily="34" charset="-122"/>
-                <a:cs typeface="Cambria" pitchFamily="34" charset="-120"/>
-              </a:rPr>
-              <a:t>Write the anatomical spec</a:t>
+                <a:latin typeface="Calibri" pitchFamily="34" charset="0"/>
+                <a:ea typeface="Calibri" pitchFamily="34" charset="-122"/>
+                <a:cs typeface="Calibri" pitchFamily="34" charset="-120"/>
+              </a:rPr>
+              <a:t>Parking lot:  revisit the supplier questionnaire.</a:t>
             </a:r>
             <a:endParaRPr lang="en-US" sz="1350" dirty="0"/>
-          </a:p>
-        </p:txBody>
-      </p:sp>
-      <p:sp>
-        <p:nvSpPr>
-          <p:cNvPr id="45" name="Text 43"/>
-          <p:cNvSpPr/>
-          <p:nvPr/>
-        </p:nvSpPr>
-        <p:spPr>
-          <a:xfrm>
-            <a:off x="749808" y="5504688"/>
-            <a:ext cx="3200400" cy="384048"/>
-          </a:xfrm>
-          <a:prstGeom prst="rect">
-            <a:avLst/>
-          </a:prstGeom>
-          <a:noFill/>
-          <a:ln/>
-        </p:spPr>
-        <p:txBody>
-          <a:bodyPr wrap="square" lIns="0" tIns="0" rIns="0" bIns="0" rtlCol="0" anchor="ctr"/>
-          <a:lstStyle/>
-          <a:p>
-            <a:pPr indent="0" marL="0">
-              <a:buNone/>
-            </a:pPr>
-            <a:r>
-              <a:rPr lang="en-US" sz="1100" dirty="0">
-                <a:solidFill>
-                  <a:srgbClr val="6E6E6E"/>
-                </a:solidFill>
-                <a:latin typeface="Calibri" pitchFamily="34" charset="0"/>
-                <a:ea typeface="Calibri" pitchFamily="34" charset="-122"/>
-                <a:cs typeface="Calibri" pitchFamily="34" charset="-120"/>
-              </a:rPr>
-              <a:t>Sow or market hog? It decides half the list.</a:t>
-            </a:r>
-            <a:endParaRPr lang="en-US" sz="1100" dirty="0"/>
-          </a:p>
-        </p:txBody>
-      </p:sp>
-      <p:sp>
-        <p:nvSpPr>
-          <p:cNvPr id="46" name="Shape 44"/>
-          <p:cNvSpPr/>
-          <p:nvPr/>
-        </p:nvSpPr>
-        <p:spPr>
-          <a:xfrm>
-            <a:off x="4325112" y="5138928"/>
-            <a:ext cx="3566160" cy="822960"/>
-          </a:xfrm>
-          <a:prstGeom prst="roundRect">
-            <a:avLst>
-              <a:gd name="adj" fmla="val 8889"/>
-            </a:avLst>
-          </a:prstGeom>
-          <a:solidFill>
-            <a:srgbClr val="F7F0F1"/>
-          </a:solidFill>
-          <a:ln w="12700">
-            <a:solidFill>
-              <a:srgbClr val="F7F0F1"/>
-            </a:solidFill>
-            <a:prstDash val="solid"/>
-          </a:ln>
-        </p:spPr>
-      </p:sp>
-      <p:sp>
-        <p:nvSpPr>
-          <p:cNvPr id="47" name="Text 45"/>
-          <p:cNvSpPr/>
-          <p:nvPr/>
-        </p:nvSpPr>
-        <p:spPr>
-          <a:xfrm>
-            <a:off x="4526280" y="5230368"/>
-            <a:ext cx="3200400" cy="274320"/>
-          </a:xfrm>
-          <a:prstGeom prst="rect">
-            <a:avLst/>
-          </a:prstGeom>
-          <a:noFill/>
-          <a:ln/>
-        </p:spPr>
-        <p:txBody>
-          <a:bodyPr wrap="square" lIns="0" tIns="0" rIns="0" bIns="0" rtlCol="0" anchor="ctr"/>
-          <a:lstStyle/>
-          <a:p>
-            <a:pPr indent="0" marL="0">
-              <a:buNone/>
-            </a:pPr>
-            <a:r>
-              <a:rPr lang="en-US" sz="1350" b="1" dirty="0">
-                <a:solidFill>
-                  <a:srgbClr val="6D2E46"/>
-                </a:solidFill>
-                <a:latin typeface="Cambria" pitchFamily="34" charset="0"/>
-                <a:ea typeface="Cambria" pitchFamily="34" charset="-122"/>
-                <a:cs typeface="Cambria" pitchFamily="34" charset="-120"/>
-              </a:rPr>
-              <a:t>Email APHIS VS</a:t>
-            </a:r>
-            <a:endParaRPr lang="en-US" sz="1350" dirty="0"/>
-          </a:p>
-        </p:txBody>
-      </p:sp>
-      <p:sp>
-        <p:nvSpPr>
-          <p:cNvPr id="48" name="Text 46"/>
-          <p:cNvSpPr/>
-          <p:nvPr/>
-        </p:nvSpPr>
-        <p:spPr>
-          <a:xfrm>
-            <a:off x="4526280" y="5504688"/>
-            <a:ext cx="3200400" cy="384048"/>
-          </a:xfrm>
-          <a:prstGeom prst="rect">
-            <a:avLst/>
-          </a:prstGeom>
-          <a:noFill/>
-          <a:ln/>
-        </p:spPr>
-        <p:txBody>
-          <a:bodyPr wrap="square" lIns="0" tIns="0" rIns="0" bIns="0" rtlCol="0" anchor="ctr"/>
-          <a:lstStyle/>
-          <a:p>
-            <a:pPr indent="0" marL="0">
-              <a:buNone/>
-            </a:pPr>
-            <a:r>
-              <a:rPr lang="en-US" sz="1100" dirty="0">
-                <a:solidFill>
-                  <a:srgbClr val="6E6E6E"/>
-                </a:solidFill>
-                <a:latin typeface="Calibri" pitchFamily="34" charset="0"/>
-                <a:ea typeface="Calibri" pitchFamily="34" charset="-122"/>
-                <a:cs typeface="Calibri" pitchFamily="34" charset="-120"/>
-              </a:rPr>
-              <a:t>What must a federal plant hold to carry EU work.</a:t>
-            </a:r>
-            <a:endParaRPr lang="en-US" sz="1100" dirty="0"/>
-          </a:p>
-        </p:txBody>
-      </p:sp>
-      <p:sp>
-        <p:nvSpPr>
-          <p:cNvPr id="49" name="Shape 47"/>
-          <p:cNvSpPr/>
-          <p:nvPr/>
-        </p:nvSpPr>
-        <p:spPr>
-          <a:xfrm>
-            <a:off x="8101584" y="5138928"/>
-            <a:ext cx="3566160" cy="822960"/>
-          </a:xfrm>
-          <a:prstGeom prst="roundRect">
-            <a:avLst>
-              <a:gd name="adj" fmla="val 8889"/>
-            </a:avLst>
-          </a:prstGeom>
-          <a:solidFill>
-            <a:srgbClr val="F7F0F1"/>
-          </a:solidFill>
-          <a:ln w="12700">
-            <a:solidFill>
-              <a:srgbClr val="F7F0F1"/>
-            </a:solidFill>
-            <a:prstDash val="solid"/>
-          </a:ln>
-        </p:spPr>
-      </p:sp>
-      <p:sp>
-        <p:nvSpPr>
-          <p:cNvPr id="50" name="Text 48"/>
-          <p:cNvSpPr/>
-          <p:nvPr/>
-        </p:nvSpPr>
-        <p:spPr>
-          <a:xfrm>
-            <a:off x="8302752" y="5230368"/>
-            <a:ext cx="3200400" cy="274320"/>
-          </a:xfrm>
-          <a:prstGeom prst="rect">
-            <a:avLst/>
-          </a:prstGeom>
-          <a:noFill/>
-          <a:ln/>
-        </p:spPr>
-        <p:txBody>
-          <a:bodyPr wrap="square" lIns="0" tIns="0" rIns="0" bIns="0" rtlCol="0" anchor="ctr"/>
-          <a:lstStyle/>
-          <a:p>
-            <a:pPr indent="0" marL="0">
-              <a:buNone/>
-            </a:pPr>
-            <a:r>
-              <a:rPr lang="en-US" sz="1350" b="1" dirty="0">
-                <a:solidFill>
-                  <a:srgbClr val="6D2E46"/>
-                </a:solidFill>
-                <a:latin typeface="Cambria" pitchFamily="34" charset="0"/>
-                <a:ea typeface="Cambria" pitchFamily="34" charset="-122"/>
-                <a:cs typeface="Cambria" pitchFamily="34" charset="-120"/>
-              </a:rPr>
-              <a:t>Interview the collectors</a:t>
-            </a:r>
-            <a:endParaRPr lang="en-US" sz="1350" dirty="0"/>
-          </a:p>
-        </p:txBody>
-      </p:sp>
-      <p:sp>
-        <p:nvSpPr>
-          <p:cNvPr id="51" name="Text 49"/>
-          <p:cNvSpPr/>
-          <p:nvPr/>
-        </p:nvSpPr>
-        <p:spPr>
-          <a:xfrm>
-            <a:off x="8302752" y="5504688"/>
-            <a:ext cx="3200400" cy="384048"/>
-          </a:xfrm>
-          <a:prstGeom prst="rect">
-            <a:avLst/>
-          </a:prstGeom>
-          <a:noFill/>
-          <a:ln/>
-        </p:spPr>
-        <p:txBody>
-          <a:bodyPr wrap="square" lIns="0" tIns="0" rIns="0" bIns="0" rtlCol="0" anchor="ctr"/>
-          <a:lstStyle/>
-          <a:p>
-            <a:pPr indent="0" marL="0">
-              <a:buNone/>
-            </a:pPr>
-            <a:r>
-              <a:rPr lang="en-US" sz="1100" dirty="0">
-                <a:solidFill>
-                  <a:srgbClr val="6E6E6E"/>
-                </a:solidFill>
-                <a:latin typeface="Calibri" pitchFamily="34" charset="0"/>
-                <a:ea typeface="Calibri" pitchFamily="34" charset="-122"/>
-                <a:cs typeface="Calibri" pitchFamily="34" charset="-120"/>
-              </a:rPr>
-              <a:t>They already run Model A inside other plants.</a:t>
-            </a:r>
-            <a:endParaRPr lang="en-US" sz="1100" dirty="0"/>
-          </a:p>
-        </p:txBody>
-      </p:sp>
-      <p:sp>
-        <p:nvSpPr>
-          <p:cNvPr id="52" name="Text 50"/>
-          <p:cNvSpPr/>
-          <p:nvPr/>
-        </p:nvSpPr>
-        <p:spPr>
-          <a:xfrm>
-            <a:off x="548640" y="6108192"/>
-            <a:ext cx="11064240" cy="292608"/>
-          </a:xfrm>
-          <a:prstGeom prst="rect">
-            <a:avLst/>
-          </a:prstGeom>
-          <a:noFill/>
-          <a:ln/>
-        </p:spPr>
-        <p:txBody>
-          <a:bodyPr wrap="square" lIns="0" tIns="0" rIns="0" bIns="0" rtlCol="0" anchor="ctr"/>
-          <a:lstStyle/>
-          <a:p>
-            <a:pPr indent="0" marL="0">
-              <a:buNone/>
-            </a:pPr>
-            <a:r>
-              <a:rPr lang="en-US" sz="1300" i="1" dirty="0">
-                <a:solidFill>
-                  <a:srgbClr val="6D2E46"/>
-                </a:solidFill>
-                <a:latin typeface="Calibri" pitchFamily="34" charset="0"/>
-                <a:ea typeface="Calibri" pitchFamily="34" charset="-122"/>
-                <a:cs typeface="Calibri" pitchFamily="34" charset="-120"/>
-              </a:rPr>
-              <a:t>Parking lot:  revisit the supplier questionnaire.</a:t>
-            </a:r>
-            <a:endParaRPr lang="en-US" sz="1300" dirty="0"/>
           </a:p>
         </p:txBody>
       </p:sp>

</xml_diff>